<commit_message>
docs(progress): 07 도표 1 예외 상자 문구 'AI 가 물러남' -> 'AI 가 처리 안될 때'
Co-Authored-By: Claude Fable 5.1 <noreply@anthropic.com>
</commit_message>
<xml_diff>
--- a/docs/project_progress/img/07/07_slides.pptx
+++ b/docs/project_progress/img/07/07_slides.pptx
@@ -5626,8 +5626,8 @@
         </p:nvSpPr>
         <p:spPr>
           <a:xfrm>
-            <a:off x="2293766" y="5160467"/>
-            <a:ext cx="1380526" cy="213326"/>
+            <a:off x="1986729" y="5160467"/>
+            <a:ext cx="1994601" cy="213326"/>
           </a:xfrm>
           <a:prstGeom prst="rect">
             <a:avLst/>
@@ -5648,7 +5648,7 @@
                 </a:solidFill>
                 <a:latin typeface="Malgun Gothic"/>
               </a:rPr>
-              <a:t>AI 가 물러남</a:t>
+              <a:t>AI 가 처리 안될 때</a:t>
             </a:r>
           </a:p>
         </p:txBody>

</xml_diff>

<commit_message>
docs(progress): 07 요약본 §4 SKMS 서술 축약
Co-Authored-By: Claude Fable 5.1 <noreply@anthropic.com>
</commit_message>
<xml_diff>
--- a/docs/project_progress/img/07/07_slides.pptx
+++ b/docs/project_progress/img/07/07_slides.pptx
@@ -6543,7 +6543,7 @@
         </p:nvGraphicFramePr>
         <p:xfrm>
           <a:off x="457200" y="1097280"/>
-          <a:ext cx="11277293" cy="2560320"/>
+          <a:ext cx="11277293" cy="1828800"/>
         </p:xfrm>
         <a:graphic>
           <a:graphicData uri="http://schemas.openxmlformats.org/drawingml/2006/table">
@@ -6552,9 +6552,9 @@
                 <a:tableStyleId>{5C22544A-7EE6-4342-B048-85BDC9FD1C3A}</a:tableStyleId>
               </a:tblPr>
               <a:tblGrid>
-                <a:gridCol w="1253032"/>
-                <a:gridCol w="6265163"/>
-                <a:gridCol w="3759098"/>
+                <a:gridCol w="1650335"/>
+                <a:gridCol w="6051231"/>
+                <a:gridCol w="3575727"/>
               </a:tblGrid>
               <a:tr h="365760">
                 <a:tc>
@@ -6563,7 +6563,7 @@
                     <a:lstStyle/>
                     <a:p>
                       <a:r>
-                        <a:rPr sz="1350" b="1">
+                        <a:rPr sz="1450" b="1">
                           <a:solidFill>
                             <a:srgbClr val="FFFFFF"/>
                           </a:solidFill>
@@ -6609,7 +6609,7 @@
                     <a:lstStyle/>
                     <a:p>
                       <a:r>
-                        <a:rPr sz="1350" b="1">
+                        <a:rPr sz="1450" b="1">
                           <a:solidFill>
                             <a:srgbClr val="FFFFFF"/>
                           </a:solidFill>
@@ -6655,7 +6655,7 @@
                     <a:lstStyle/>
                     <a:p>
                       <a:r>
-                        <a:rPr sz="1350" b="1">
+                        <a:rPr sz="1450" b="1">
                           <a:solidFill>
                             <a:srgbClr val="FFFFFF"/>
                           </a:solidFill>
@@ -6703,7 +6703,7 @@
                     <a:lstStyle/>
                     <a:p>
                       <a:r>
-                        <a:rPr sz="1300" b="1">
+                        <a:rPr sz="1400" b="1">
                           <a:solidFill>
                             <a:srgbClr val="1F2328"/>
                           </a:solidFill>
@@ -6749,13 +6749,13 @@
                     <a:lstStyle/>
                     <a:p>
                       <a:r>
-                        <a:rPr sz="1300" b="0">
+                        <a:rPr sz="1400" b="0">
                           <a:solidFill>
                             <a:srgbClr val="1F2328"/>
                           </a:solidFill>
                           <a:latin typeface="Malgun Gothic"/>
                         </a:rPr>
-                        <a:t>알람을 10초마다 조회해 Align Fail만 골라 발동. 접속 후 화면에서 라이브 영역·촬영 모드·타인 점유를 읽음</a:t>
+                        <a:t>알람을 10초마다 조회해 Align Fail만 발동, 접속 후 화면 상태를 읽음</a:t>
                       </a:r>
                     </a:p>
                   </a:txBody>
@@ -6795,13 +6795,13 @@
                     <a:lstStyle/>
                     <a:p>
                       <a:r>
-                        <a:rPr sz="1300" b="0">
+                        <a:rPr sz="1400" b="0">
                           <a:solidFill>
                             <a:srgbClr val="1F2328"/>
                           </a:solidFill>
                           <a:latin typeface="Malgun Gothic"/>
                         </a:rPr>
-                        <a:t>24시간 모니터 감시가 자동화되고 화면 상태를 시스템이 먼저 읽음</a:t>
+                        <a:t>24시간 모니터 감시 자동화</a:t>
                       </a:r>
                     </a:p>
                   </a:txBody>
@@ -6843,7 +6843,7 @@
                     <a:lstStyle/>
                     <a:p>
                       <a:r>
-                        <a:rPr sz="1300" b="1">
+                        <a:rPr sz="1400" b="1">
                           <a:solidFill>
                             <a:srgbClr val="1F2328"/>
                           </a:solidFill>
@@ -6889,13 +6889,13 @@
                     <a:lstStyle/>
                     <a:p>
                       <a:r>
-                        <a:rPr sz="1300" b="0">
+                        <a:rPr sz="1400" b="0">
                           <a:solidFill>
                             <a:srgbClr val="1F2328"/>
                           </a:solidFill>
                           <a:latin typeface="Malgun Gothic"/>
                         </a:rPr>
-                        <a:t>RCS 접속 → 녹화 → 최근 성공 사례 기준으로 위치 계산 → 재정렬 → 확정 → 측정 재개 감시 → 종료</a:t>
+                        <a:t>RCS 접속 → 녹화 → 성공 사례 기준 재정렬 → 확정 → 종료</a:t>
                       </a:r>
                     </a:p>
                   </a:txBody>
@@ -6935,7 +6935,7 @@
                     <a:lstStyle/>
                     <a:p>
                       <a:r>
-                        <a:rPr sz="1300" b="0">
+                        <a:rPr sz="1400" b="0">
                           <a:solidFill>
                             <a:srgbClr val="1F2328"/>
                           </a:solidFill>
@@ -6983,13 +6983,13 @@
                     <a:lstStyle/>
                     <a:p>
                       <a:r>
-                        <a:rPr sz="1300" b="1">
+                        <a:rPr sz="1400" b="1">
                           <a:solidFill>
                             <a:srgbClr val="1F2328"/>
                           </a:solidFill>
                           <a:latin typeface="Malgun Gothic"/>
                         </a:rPr>
-                        <a:t>판단 지원</a:t>
+                        <a:t>이상치 필터·예외 알림</a:t>
                       </a:r>
                     </a:p>
                   </a:txBody>
@@ -7029,13 +7029,13 @@
                     <a:lstStyle/>
                     <a:p>
                       <a:r>
-                        <a:rPr sz="1300" b="0">
+                        <a:rPr sz="1400" b="0">
                           <a:solidFill>
                             <a:srgbClr val="1F2328"/>
                           </a:solidFill>
                           <a:latin typeface="Malgun Gothic"/>
                         </a:rPr>
-                        <a:t>헷갈리는 Align Key Recipe를 재등록 검토 후보로 제시, 대응 기록의 실패 분포 집계</a:t>
+                        <a:t>확인 안 되면 클릭·보정 보류, 원인·요구 행동을 담아 담당자에게 큐브 알림</a:t>
                       </a:r>
                     </a:p>
                   </a:txBody>
@@ -7075,13 +7075,13 @@
                     <a:lstStyle/>
                     <a:p>
                       <a:r>
-                        <a:rPr sz="1300" b="0">
+                        <a:rPr sz="1400" b="0">
                           <a:solidFill>
                             <a:srgbClr val="1F2328"/>
                           </a:solidFill>
                           <a:latin typeface="Malgun Gothic"/>
                         </a:rPr>
-                        <a:t>"무엇을 먼저 고칠지"를 감이 아니라 데이터로</a:t>
+                        <a:t>불확실한 조작은 하지 않고 담당자는 예외만 판단</a:t>
                       </a:r>
                     </a:p>
                   </a:txBody>
@@ -7123,13 +7123,13 @@
                     <a:lstStyle/>
                     <a:p>
                       <a:r>
-                        <a:rPr sz="1300" b="1">
+                        <a:rPr sz="1400" b="1">
                           <a:solidFill>
                             <a:srgbClr val="1F2328"/>
                           </a:solidFill>
                           <a:latin typeface="Malgun Gothic"/>
                         </a:rPr>
-                        <a:t>이상치 필터</a:t>
+                        <a:t>기록·자산화</a:t>
                       </a:r>
                     </a:p>
                   </a:txBody>
@@ -7169,13 +7169,13 @@
                     <a:lstStyle/>
                     <a:p>
                       <a:r>
-                        <a:rPr sz="1300" b="0">
+                        <a:rPr sz="1400" b="0">
                           <a:solidFill>
                             <a:srgbClr val="1F2328"/>
                           </a:solidFill>
                           <a:latin typeface="Malgun Gothic"/>
                         </a:rPr>
-                        <a:t>버튼을 못 찾거나 라벨이 다르거나 모드를 못 읽으면 클릭·보정 보류. 보정 뒤 오측이 보이면 후속 측정 중단</a:t>
+                        <a:t>대응 1건 = 기록 1줄, 실패 화면·녹화 보존, 재등록 검토 후보 산출</a:t>
                       </a:r>
                     </a:p>
                   </a:txBody>
@@ -7215,293 +7215,13 @@
                     <a:lstStyle/>
                     <a:p>
                       <a:r>
-                        <a:rPr sz="1300" b="0">
+                        <a:rPr sz="1400" b="0">
                           <a:solidFill>
                             <a:srgbClr val="1F2328"/>
                           </a:solidFill>
                           <a:latin typeface="Malgun Gothic"/>
                         </a:rPr>
-                        <a:t>불확실한 조작은 하지 않음</a:t>
-                      </a:r>
-                    </a:p>
-                  </a:txBody>
-                  <a:tcPr marL="88900" marR="88900" marT="63500" marB="63500" anchor="ctr">
-                    <a:lnL w="9525" cap="flat" cmpd="sng" algn="ctr">
-                      <a:solidFill>
-                        <a:srgbClr val="D0D7DE"/>
-                      </a:solidFill>
-                      <a:prstDash val="solid"/>
-                    </a:lnL>
-                    <a:lnR w="9525" cap="flat" cmpd="sng" algn="ctr">
-                      <a:solidFill>
-                        <a:srgbClr val="D0D7DE"/>
-                      </a:solidFill>
-                      <a:prstDash val="solid"/>
-                    </a:lnR>
-                    <a:lnT w="9525" cap="flat" cmpd="sng" algn="ctr">
-                      <a:solidFill>
-                        <a:srgbClr val="D0D7DE"/>
-                      </a:solidFill>
-                      <a:prstDash val="solid"/>
-                    </a:lnT>
-                    <a:lnB w="9525" cap="flat" cmpd="sng" algn="ctr">
-                      <a:solidFill>
-                        <a:srgbClr val="D0D7DE"/>
-                      </a:solidFill>
-                      <a:prstDash val="solid"/>
-                    </a:lnB>
-                    <a:solidFill>
-                      <a:srgbClr val="F6F8FA"/>
-                    </a:solidFill>
-                  </a:tcPr>
-                </a:tc>
-              </a:tr>
-              <a:tr h="365760">
-                <a:tc>
-                  <a:txBody>
-                    <a:bodyPr wrap="square"/>
-                    <a:lstStyle/>
-                    <a:p>
-                      <a:r>
-                        <a:rPr sz="1300" b="1">
-                          <a:solidFill>
-                            <a:srgbClr val="1F2328"/>
-                          </a:solidFill>
-                          <a:latin typeface="Malgun Gothic"/>
-                        </a:rPr>
-                        <a:t>예외 알림</a:t>
-                      </a:r>
-                    </a:p>
-                  </a:txBody>
-                  <a:tcPr marL="88900" marR="88900" marT="63500" marB="63500" anchor="ctr">
-                    <a:lnL w="9525" cap="flat" cmpd="sng" algn="ctr">
-                      <a:solidFill>
-                        <a:srgbClr val="D0D7DE"/>
-                      </a:solidFill>
-                      <a:prstDash val="solid"/>
-                    </a:lnL>
-                    <a:lnR w="9525" cap="flat" cmpd="sng" algn="ctr">
-                      <a:solidFill>
-                        <a:srgbClr val="D0D7DE"/>
-                      </a:solidFill>
-                      <a:prstDash val="solid"/>
-                    </a:lnR>
-                    <a:lnT w="9525" cap="flat" cmpd="sng" algn="ctr">
-                      <a:solidFill>
-                        <a:srgbClr val="D0D7DE"/>
-                      </a:solidFill>
-                      <a:prstDash val="solid"/>
-                    </a:lnT>
-                    <a:lnB w="9525" cap="flat" cmpd="sng" algn="ctr">
-                      <a:solidFill>
-                        <a:srgbClr val="D0D7DE"/>
-                      </a:solidFill>
-                      <a:prstDash val="solid"/>
-                    </a:lnB>
-                    <a:solidFill>
-                      <a:srgbClr val="FFFFFF"/>
-                    </a:solidFill>
-                  </a:tcPr>
-                </a:tc>
-                <a:tc>
-                  <a:txBody>
-                    <a:bodyPr wrap="square"/>
-                    <a:lstStyle/>
-                    <a:p>
-                      <a:r>
-                        <a:rPr sz="1300" b="0">
-                          <a:solidFill>
-                            <a:srgbClr val="1F2328"/>
-                          </a:solidFill>
-                          <a:latin typeface="Malgun Gothic"/>
-                        </a:rPr>
-                        <a:t>AI가 진행 못하면 원인·요구 행동을 담아 담당자에게 큐브 알림. 설정 문제와 재등록 검토를 구분</a:t>
-                      </a:r>
-                    </a:p>
-                  </a:txBody>
-                  <a:tcPr marL="88900" marR="88900" marT="63500" marB="63500" anchor="ctr">
-                    <a:lnL w="9525" cap="flat" cmpd="sng" algn="ctr">
-                      <a:solidFill>
-                        <a:srgbClr val="D0D7DE"/>
-                      </a:solidFill>
-                      <a:prstDash val="solid"/>
-                    </a:lnL>
-                    <a:lnR w="9525" cap="flat" cmpd="sng" algn="ctr">
-                      <a:solidFill>
-                        <a:srgbClr val="D0D7DE"/>
-                      </a:solidFill>
-                      <a:prstDash val="solid"/>
-                    </a:lnR>
-                    <a:lnT w="9525" cap="flat" cmpd="sng" algn="ctr">
-                      <a:solidFill>
-                        <a:srgbClr val="D0D7DE"/>
-                      </a:solidFill>
-                      <a:prstDash val="solid"/>
-                    </a:lnT>
-                    <a:lnB w="9525" cap="flat" cmpd="sng" algn="ctr">
-                      <a:solidFill>
-                        <a:srgbClr val="D0D7DE"/>
-                      </a:solidFill>
-                      <a:prstDash val="solid"/>
-                    </a:lnB>
-                    <a:solidFill>
-                      <a:srgbClr val="FFFFFF"/>
-                    </a:solidFill>
-                  </a:tcPr>
-                </a:tc>
-                <a:tc>
-                  <a:txBody>
-                    <a:bodyPr wrap="square"/>
-                    <a:lstStyle/>
-                    <a:p>
-                      <a:r>
-                        <a:rPr sz="1300" b="0">
-                          <a:solidFill>
-                            <a:srgbClr val="1F2328"/>
-                          </a:solidFill>
-                          <a:latin typeface="Malgun Gothic"/>
-                        </a:rPr>
-                        <a:t>담당자는 예외만 판단, 다음 행동의 근거 확보</a:t>
-                      </a:r>
-                    </a:p>
-                  </a:txBody>
-                  <a:tcPr marL="88900" marR="88900" marT="63500" marB="63500" anchor="ctr">
-                    <a:lnL w="9525" cap="flat" cmpd="sng" algn="ctr">
-                      <a:solidFill>
-                        <a:srgbClr val="D0D7DE"/>
-                      </a:solidFill>
-                      <a:prstDash val="solid"/>
-                    </a:lnL>
-                    <a:lnR w="9525" cap="flat" cmpd="sng" algn="ctr">
-                      <a:solidFill>
-                        <a:srgbClr val="D0D7DE"/>
-                      </a:solidFill>
-                      <a:prstDash val="solid"/>
-                    </a:lnR>
-                    <a:lnT w="9525" cap="flat" cmpd="sng" algn="ctr">
-                      <a:solidFill>
-                        <a:srgbClr val="D0D7DE"/>
-                      </a:solidFill>
-                      <a:prstDash val="solid"/>
-                    </a:lnT>
-                    <a:lnB w="9525" cap="flat" cmpd="sng" algn="ctr">
-                      <a:solidFill>
-                        <a:srgbClr val="D0D7DE"/>
-                      </a:solidFill>
-                      <a:prstDash val="solid"/>
-                    </a:lnB>
-                    <a:solidFill>
-                      <a:srgbClr val="FFFFFF"/>
-                    </a:solidFill>
-                  </a:tcPr>
-                </a:tc>
-              </a:tr>
-              <a:tr h="365760">
-                <a:tc>
-                  <a:txBody>
-                    <a:bodyPr wrap="square"/>
-                    <a:lstStyle/>
-                    <a:p>
-                      <a:r>
-                        <a:rPr sz="1300" b="1">
-                          <a:solidFill>
-                            <a:srgbClr val="1F2328"/>
-                          </a:solidFill>
-                          <a:latin typeface="Malgun Gothic"/>
-                        </a:rPr>
-                        <a:t>기록·자산화</a:t>
-                      </a:r>
-                    </a:p>
-                  </a:txBody>
-                  <a:tcPr marL="88900" marR="88900" marT="63500" marB="63500" anchor="ctr">
-                    <a:lnL w="9525" cap="flat" cmpd="sng" algn="ctr">
-                      <a:solidFill>
-                        <a:srgbClr val="D0D7DE"/>
-                      </a:solidFill>
-                      <a:prstDash val="solid"/>
-                    </a:lnL>
-                    <a:lnR w="9525" cap="flat" cmpd="sng" algn="ctr">
-                      <a:solidFill>
-                        <a:srgbClr val="D0D7DE"/>
-                      </a:solidFill>
-                      <a:prstDash val="solid"/>
-                    </a:lnR>
-                    <a:lnT w="9525" cap="flat" cmpd="sng" algn="ctr">
-                      <a:solidFill>
-                        <a:srgbClr val="D0D7DE"/>
-                      </a:solidFill>
-                      <a:prstDash val="solid"/>
-                    </a:lnT>
-                    <a:lnB w="9525" cap="flat" cmpd="sng" algn="ctr">
-                      <a:solidFill>
-                        <a:srgbClr val="D0D7DE"/>
-                      </a:solidFill>
-                      <a:prstDash val="solid"/>
-                    </a:lnB>
-                    <a:solidFill>
-                      <a:srgbClr val="F6F8FA"/>
-                    </a:solidFill>
-                  </a:tcPr>
-                </a:tc>
-                <a:tc>
-                  <a:txBody>
-                    <a:bodyPr wrap="square"/>
-                    <a:lstStyle/>
-                    <a:p>
-                      <a:r>
-                        <a:rPr sz="1300" b="0">
-                          <a:solidFill>
-                            <a:srgbClr val="1F2328"/>
-                          </a:solidFill>
-                          <a:latin typeface="Malgun Gothic"/>
-                        </a:rPr>
-                        <a:t>대응 1건 = 기록 1줄, 실패 화면·녹화 보존. 수동 조작 녹화 → 절차서 변환 경로</a:t>
-                      </a:r>
-                    </a:p>
-                  </a:txBody>
-                  <a:tcPr marL="88900" marR="88900" marT="63500" marB="63500" anchor="ctr">
-                    <a:lnL w="9525" cap="flat" cmpd="sng" algn="ctr">
-                      <a:solidFill>
-                        <a:srgbClr val="D0D7DE"/>
-                      </a:solidFill>
-                      <a:prstDash val="solid"/>
-                    </a:lnL>
-                    <a:lnR w="9525" cap="flat" cmpd="sng" algn="ctr">
-                      <a:solidFill>
-                        <a:srgbClr val="D0D7DE"/>
-                      </a:solidFill>
-                      <a:prstDash val="solid"/>
-                    </a:lnR>
-                    <a:lnT w="9525" cap="flat" cmpd="sng" algn="ctr">
-                      <a:solidFill>
-                        <a:srgbClr val="D0D7DE"/>
-                      </a:solidFill>
-                      <a:prstDash val="solid"/>
-                    </a:lnT>
-                    <a:lnB w="9525" cap="flat" cmpd="sng" algn="ctr">
-                      <a:solidFill>
-                        <a:srgbClr val="D0D7DE"/>
-                      </a:solidFill>
-                      <a:prstDash val="solid"/>
-                    </a:lnB>
-                    <a:solidFill>
-                      <a:srgbClr val="F6F8FA"/>
-                    </a:solidFill>
-                  </a:tcPr>
-                </a:tc>
-                <a:tc>
-                  <a:txBody>
-                    <a:bodyPr wrap="square"/>
-                    <a:lstStyle/>
-                    <a:p>
-                      <a:r>
-                        <a:rPr sz="1300" b="0">
-                          <a:solidFill>
-                            <a:srgbClr val="1F2328"/>
-                          </a:solidFill>
-                          <a:latin typeface="Malgun Gothic"/>
-                        </a:rPr>
-                        <a:t>개인 경험이 기록으로 남고 개선 근거가 쌓임</a:t>
+                        <a:t>개선 순서를 감이 아니라 데이터로</a:t>
                       </a:r>
                     </a:p>
                   </a:txBody>

</xml_diff>

<commit_message>
docs(progress): 07 문서·도표의 '웨이퍼'/'WAFER' 를 'Wafer' 로 통일
Co-Authored-By: Claude Fable 5.1 <noreply@anthropic.com>
</commit_message>
<xml_diff>
--- a/docs/project_progress/img/07/07_slides.pptx
+++ b/docs/project_progress/img/07/07_slides.pptx
@@ -10872,8 +10872,8 @@
         </p:nvSpPr>
         <p:spPr>
           <a:xfrm>
-            <a:off x="8417821" y="5771241"/>
-            <a:ext cx="3354176" cy="177772"/>
+            <a:off x="8438455" y="5771241"/>
+            <a:ext cx="3312908" cy="177772"/>
           </a:xfrm>
           <a:prstGeom prst="rect">
             <a:avLst/>
@@ -10894,7 +10894,7 @@
                 </a:solidFill>
                 <a:latin typeface="Malgun Gothic"/>
               </a:rPr>
-              <a:t>≈ 웨이퍼 100장/주 · Capex 약 4~5억 원</a:t>
+              <a:t>≈ Wafer 100장/주 · Capex 약 4~5억 원</a:t>
             </a:r>
           </a:p>
         </p:txBody>
@@ -13080,7 +13080,7 @@
                           </a:solidFill>
                           <a:latin typeface="Malgun Gothic"/>
                         </a:rPr>
-                        <a:t>WAFER 약 100장/주</a:t>
+                        <a:t>Wafer 약 100장/주</a:t>
                       </a:r>
                       <a:r>
                         <a:rPr sz="1400" b="0">
@@ -15412,7 +15412,7 @@
                           </a:solidFill>
                           <a:latin typeface="Malgun Gothic"/>
                         </a:rPr>
-                        <a:t> = WAFER 약 100장/주 = 장비 약 0.2대(Capex 약 4~5억 원)</a:t>
+                        <a:t> = Wafer 약 100장/주 = 장비 약 0.2대(Capex 약 4~5억 원)</a:t>
                       </a:r>
                     </a:p>
                   </a:txBody>

</xml_diff>

<commit_message>
docs(progress): 07 도표 1 After 결과 카드에서 '실알람 3건' 삭제
Co-Authored-By: Claude Fable 5.1 <noreply@anthropic.com>
</commit_message>
<xml_diff>
--- a/docs/project_progress/img/07/07_slides.pptx
+++ b/docs/project_progress/img/07/07_slides.pptx
@@ -5381,8 +5381,8 @@
         </p:nvSpPr>
         <p:spPr>
           <a:xfrm>
-            <a:off x="9860695" y="4367477"/>
-            <a:ext cx="2373129" cy="195549"/>
+            <a:off x="10473532" y="4367477"/>
+            <a:ext cx="1147454" cy="195549"/>
           </a:xfrm>
           <a:prstGeom prst="rect">
             <a:avLst/>
@@ -5403,7 +5403,7 @@
                 </a:solidFill>
                 <a:latin typeface="Malgun Gothic"/>
               </a:rPr>
-              <a:t>감지~재조정 · 실알람 3건</a:t>
+              <a:t>감지~재조정</a:t>
             </a:r>
           </a:p>
         </p:txBody>

</xml_diff>

<commit_message>
docs(progress): 07 요약본 OCR 을 AI 모델(PaddleOCR-VL)로 명시, 그림 2 OCR pill 교체
Co-Authored-By: Claude Fable 5.1 <noreply@anthropic.com>
</commit_message>
<xml_diff>
--- a/docs/project_progress/img/07/07_slides.pptx
+++ b/docs/project_progress/img/07/07_slides.pptx
@@ -8021,8 +8021,8 @@
         </p:nvSpPr>
         <p:spPr>
           <a:xfrm>
-            <a:off x="3030568" y="4075423"/>
-            <a:ext cx="3208403" cy="195549"/>
+            <a:off x="3071423" y="4075423"/>
+            <a:ext cx="3126692" cy="195549"/>
           </a:xfrm>
           <a:prstGeom prst="rect">
             <a:avLst/>
@@ -8043,7 +8043,7 @@
                 </a:solidFill>
                 <a:latin typeface="Malgun Gothic"/>
               </a:rPr>
-              <a:t>fail-closed : 미확인 = 클릭 금지</a:t>
+              <a:t>사내 소형 AI 모델 · fail-closed</a:t>
             </a:r>
           </a:p>
         </p:txBody>
@@ -13550,9 +13550,9 @@
                 <a:tableStyleId>{5C22544A-7EE6-4342-B048-85BDC9FD1C3A}</a:tableStyleId>
               </a:tblPr>
               <a:tblGrid>
-                <a:gridCol w="2985166"/>
-                <a:gridCol w="1990110"/>
-                <a:gridCol w="6302017"/>
+                <a:gridCol w="2899875"/>
+                <a:gridCol w="1933250"/>
+                <a:gridCol w="6444168"/>
               </a:tblGrid>
               <a:tr h="365760">
                 <a:tc>
@@ -13939,7 +13939,7 @@
                           </a:solidFill>
                           <a:latin typeface="Malgun Gothic"/>
                         </a:rPr>
-                        <a:t>사내 HCP 에 VLM 1종 + OCR 1종 상시 운영</a:t>
+                        <a:t>사내 HCP 에 AI 모델 2종(VLM 1종 + OCR 1종) 상시 운영</a:t>
                       </a:r>
                     </a:p>
                   </a:txBody>

</xml_diff>

<commit_message>
docs(progress): 상세본 O/I 절 승격 + SEM 난이도 서술 정정
- 상세본도 요약본과 같은 탭 구조로: 4.2 Operation Improvement with AI 를
  '## 5' 로 승격(하위 4.2.x -> 5.1~5.3), 4.1.1/4.1.2 를 4.1 패기 / 4.2
  Teamwork 로 올리고 중복된 '4.1 SKMS 기본 정신' 소제목 제거
- 고배율 SEM 이 어려운 이유를 '반복 패턴' 으로 쓴 5곳 정정. 주기적 반복은
  저배율 OM 쪽 특성이고, SEM 은 시야가 비슷한 선·평탄면으로 채워져 위치를
  특정할 단서(선이 만나는 지점)가 드문 것이 원인이다
- 난이도 표: '실장비 클릭 오동작' -> '얼라인 위치 재설정 오동작'

Co-Authored-By: Claude Opus 5 (1M context) <noreply@anthropic.com>
</commit_message>
<xml_diff>
--- a/docs/project_progress/img/07/07_slides.pptx
+++ b/docs/project_progress/img/07/07_slides.pptx
@@ -12269,7 +12269,7 @@
                           </a:solidFill>
                           <a:latin typeface="Malgun Gothic"/>
                         </a:rPr>
-                        <a:t>고배율 SEM 화면은 반복 패턴이라 가짜 후보가 많음</a:t>
+                        <a:t>고배율 SEM 화면은 위치를 특정할 단서가 드물어 가짜 후보가 많음</a:t>
                       </a:r>
                     </a:p>
                   </a:txBody>
@@ -12363,7 +12363,7 @@
                           </a:solidFill>
                           <a:latin typeface="Malgun Gothic"/>
                         </a:rPr>
-                        <a:t>실장비 클릭 오동작 시 측정에 영향을 줌</a:t>
+                        <a:t>얼라인 위치 재설정 오동작 시 측정에 영향을 줌</a:t>
                       </a:r>
                     </a:p>
                   </a:txBody>

</xml_diff>